<commit_message>
docs: actualiza presentación con estructura actual del proyecto
</commit_message>
<xml_diff>
--- a/Tarea_Prediccion_Ventas_MLNET_ModelBuilder_Paso_a_Paso.pptx
+++ b/Tarea_Prediccion_Ventas_MLNET_ModelBuilder_Paso_a_Paso.pptx
@@ -21,6 +21,7 @@
     <p:sldId xmlns:r="http://schemas.openxmlformats.org/officeDocument/2006/relationships" id="266" r:id="R6389030a51c24394"/>
     <p:sldId xmlns:r="http://schemas.openxmlformats.org/officeDocument/2006/relationships" id="267" r:id="R42bc9e39351d409f"/>
     <p:sldId xmlns:r="http://schemas.openxmlformats.org/officeDocument/2006/relationships" id="268" r:id="R4c3c9fee23d0455a"/>
+    <p:sldId xmlns:ns0="http://schemas.openxmlformats.org/officeDocument/2006/relationships" id="269" ns0:id="rId19"/>
   </p:sldIdLst>
   <p:sldSz cx="12192000" cy="6858000"/>
   <p:notesSz cx="6858000" cy="9144000"/>
@@ -4857,7 +4858,7 @@
                 <a:ea typeface="Aptos"/>
                 <a:cs typeface="Aptos"/>
               </a:rPr>
-              <a:t>Revise el estado real del proyecto antes de capturar evidencias o presentar resultados.</a:t>
+              <a:t>Revise el estado real del repositorio antes de capturar evidencias o presentar resultados.</a:t>
             </a:r>
           </a:p>
         </p:txBody>
@@ -5066,7 +5067,7 @@
                 <a:ea typeface="Aptos"/>
                 <a:cs typeface="Aptos"/>
               </a:rPr>
-              <a:t>Predicción simulada</a:t>
+              <a:t>Data mismatch</a:t>
             </a:r>
           </a:p>
         </p:txBody>
@@ -5124,7 +5125,7 @@
                 <a:ea typeface="Aptos"/>
                 <a:cs typeface="Aptos"/>
               </a:rPr>
-              <a:t>SalesPredictionApp usa ±5 % aleatorio hasta conectar SalesModel.Predict.</a:t>
+              <a:t>El modelo debe entrenarse y consumirse con el mismo dataset (ventas_sinteticas_2025.csv).</a:t>
             </a:r>
           </a:p>
         </p:txBody>
@@ -5240,7 +5241,7 @@
                 <a:ea typeface="Aptos"/>
                 <a:cs typeface="Aptos"/>
               </a:rPr>
-              <a:t>Eliminar la simulación después de entrenar.</a:t>
+              <a:t>Verificar que SalesPredictionApp use el modelo generado desde el CSV sintetico.</a:t>
             </a:r>
           </a:p>
         </p:txBody>
@@ -5449,7 +5450,7 @@
                 <a:ea typeface="Aptos"/>
                 <a:cs typeface="Aptos"/>
               </a:rPr>
-              <a:t>Los .mbconfig generados pueden guardar rutas absolutas locales.</a:t>
+              <a:t>Los archivos .mbconfig y .training.cs pueden guardar rutas absolutas locales.</a:t>
             </a:r>
           </a:p>
         </p:txBody>
@@ -5565,7 +5566,7 @@
                 <a:ea typeface="Aptos"/>
                 <a:cs typeface="Aptos"/>
               </a:rPr>
-              <a:t>Actualizar las rutas al mover el repositorio.</a:t>
+              <a:t>Reemplazar por rutas relativas al repositorio antes de entregar.</a:t>
             </a:r>
           </a:p>
         </p:txBody>
@@ -5716,7 +5717,7 @@
                 <a:ea typeface="Aptos"/>
                 <a:cs typeface="Aptos"/>
               </a:rPr>
-              <a:t>Compatibilidad / paquetes</a:t>
+              <a:t>Proyectos experimentales</a:t>
             </a:r>
           </a:p>
         </p:txBody>
@@ -5774,7 +5775,7 @@
                 <a:ea typeface="Aptos"/>
                 <a:cs typeface="Aptos"/>
               </a:rPr>
-              <a:t>Model Builder o NuGet pueden faltar o no cargar en VS 2026.</a:t>
+              <a:t>train/, train2/, test/ y test2/ contienen versiones alternativas que pueden confundir.</a:t>
             </a:r>
           </a:p>
         </p:txBody>
@@ -5890,7 +5891,7 @@
                 <a:ea typeface="Aptos"/>
                 <a:cs typeface="Aptos"/>
               </a:rPr>
-              <a:t>Probar VS 2022 en paralelo y restaurar paquetes.</a:t>
+              <a:t>Usar solo SalesPredictionApp/ como proyecto principal y documentar el resto como respaldo.</a:t>
             </a:r>
           </a:p>
         </p:txBody>
@@ -6151,7 +6152,7 @@
                 <a:ea typeface="Aptos"/>
                 <a:cs typeface="Aptos"/>
               </a:rPr>
-              <a:t>Datos válidos → modelo evaluado → predicciones reales → dashboard → recomendaciones</a:t>
+              <a:t>Datos validos → modelo evaluado → predicciones reales → dashboard → recomendaciones</a:t>
             </a:r>
           </a:p>
         </p:txBody>
@@ -6209,76 +6210,10 @@
                 <a:ea typeface="Aptos"/>
                 <a:cs typeface="Aptos"/>
               </a:rPr>
-              <a:t>✓ CSV de entrenamiento</a:t>
-            </a:r>
-          </a:p>
-          <a:p xmlns:a="http://schemas.openxmlformats.org/drawingml/2006/main">
-            <a:pPr algn="l">
-              <a:defRPr sz="1500" b="0">
-                <a:solidFill>
-                  <a:srgbClr val="FFFFFF"/>
-                </a:solidFill>
-                <a:latin typeface="Aptos"/>
-                <a:ea typeface="Aptos"/>
-                <a:cs typeface="Aptos"/>
-              </a:defRPr>
-            </a:pPr>
-            <a:r>
-              <a:rPr sz="1500" b="0">
-                <a:solidFill>
-                  <a:srgbClr val="FFFFFF"/>
-                </a:solidFill>
-                <a:latin typeface="Aptos"/>
-                <a:ea typeface="Aptos"/>
-                <a:cs typeface="Aptos"/>
-              </a:rPr>
-              <a:t>✓ Capturas y métricas</a:t>
-            </a:r>
-          </a:p>
-          <a:p xmlns:a="http://schemas.openxmlformats.org/drawingml/2006/main">
-            <a:pPr algn="l">
-              <a:defRPr sz="1500" b="0">
-                <a:solidFill>
-                  <a:srgbClr val="FFFFFF"/>
-                </a:solidFill>
-                <a:latin typeface="Aptos"/>
-                <a:ea typeface="Aptos"/>
-                <a:cs typeface="Aptos"/>
-              </a:defRPr>
-            </a:pPr>
-            <a:r>
-              <a:rPr sz="1500" b="0">
-                <a:solidFill>
-                  <a:srgbClr val="FFFFFF"/>
-                </a:solidFill>
-                <a:latin typeface="Aptos"/>
-                <a:ea typeface="Aptos"/>
-                <a:cs typeface="Aptos"/>
-              </a:rPr>
-              <a:t>✓ resultados_prediccion.csv</a:t>
-            </a:r>
-          </a:p>
-          <a:p xmlns:a="http://schemas.openxmlformats.org/drawingml/2006/main">
-            <a:pPr algn="l">
-              <a:defRPr sz="1500" b="0">
-                <a:solidFill>
-                  <a:srgbClr val="FFFFFF"/>
-                </a:solidFill>
-                <a:latin typeface="Aptos"/>
-                <a:ea typeface="Aptos"/>
-                <a:cs typeface="Aptos"/>
-              </a:defRPr>
-            </a:pPr>
-            <a:r>
-              <a:rPr sz="1500" b="0">
-                <a:solidFill>
-                  <a:srgbClr val="FFFFFF"/>
-                </a:solidFill>
-                <a:latin typeface="Aptos"/>
-                <a:ea typeface="Aptos"/>
-                <a:cs typeface="Aptos"/>
-              </a:rPr>
-              <a:t>✓ Dashboard y conclusiones</a:t>
+              <a:t>✓ CSV de entrenamiento (ventas_sinteticas_2025.csv)
+✓ Capturas y metricas del modelo en Model Builder
+✓ resultados_prediccion.csv desde SalesPredictionApp
+✓ Dashboard y conclusiones de negocio</a:t>
             </a:r>
           </a:p>
         </p:txBody>
@@ -6336,7 +6271,7 @@
                 <a:ea typeface="Aptos"/>
                 <a:cs typeface="Aptos"/>
               </a:rPr>
-              <a:t>No entregue resultados simulados como si fueran predicciones del modelo.</a:t>
+              <a:t>No entregue predicciones simuladas ni mezcle datasets con esquemas diferentes.</a:t>
             </a:r>
           </a:p>
         </p:txBody>
@@ -6348,6 +6283,256 @@
       </p:ext>
     </p:extLst>
   </p:cSld>
+</p:sld>
+</file>
+
+<file path=ppt/slides/slide14.xml><?xml version="1.0" encoding="utf-8"?>
+<p:sld xmlns:a="http://schemas.openxmlformats.org/drawingml/2006/main" xmlns:p="http://schemas.openxmlformats.org/presentationml/2006/main" xmlns:r="http://schemas.openxmlformats.org/officeDocument/2006/relationships">
+  <p:cSld>
+    <p:spTree>
+      <p:nvGrpSpPr>
+        <p:cNvPr id="1" name=""/>
+        <p:cNvGrpSpPr/>
+        <p:nvPr/>
+      </p:nvGrpSpPr>
+      <p:grpSpPr/>
+      <p:sp>
+        <p:nvSpPr>
+          <p:cNvPr id="2" name="TextBox 1"/>
+          <p:cNvSpPr txBox="1"/>
+          <p:nvPr/>
+        </p:nvSpPr>
+        <p:spPr>
+          <a:xfrm>
+            <a:off x="457200" y="365760"/>
+            <a:ext cx="8229600" cy="731520"/>
+          </a:xfrm>
+          <a:prstGeom prst="rect">
+            <a:avLst/>
+          </a:prstGeom>
+          <a:noFill/>
+        </p:spPr>
+        <p:txBody>
+          <a:bodyPr wrap="none">
+            <a:spAutoFit/>
+          </a:bodyPr>
+          <a:lstStyle/>
+          <a:p>
+            <a:pPr>
+              <a:defRPr sz="3200" b="1">
+                <a:solidFill>
+                  <a:srgbClr val="1F4E79"/>
+                </a:solidFill>
+              </a:defRPr>
+            </a:pPr>
+            <a:r>
+              <a:t>Estructura actual del repositorio</a:t>
+            </a:r>
+          </a:p>
+        </p:txBody>
+      </p:sp>
+      <p:sp>
+        <p:nvSpPr>
+          <p:cNvPr id="3" name="TextBox 2"/>
+          <p:cNvSpPr txBox="1"/>
+          <p:nvPr/>
+        </p:nvSpPr>
+        <p:spPr>
+          <a:xfrm>
+            <a:off x="457200" y="1097280"/>
+            <a:ext cx="8229600" cy="457200"/>
+          </a:xfrm>
+          <a:prstGeom prst="rect">
+            <a:avLst/>
+          </a:prstGeom>
+          <a:noFill/>
+        </p:spPr>
+        <p:txBody>
+          <a:bodyPr wrap="none">
+            <a:spAutoFit/>
+          </a:bodyPr>
+          <a:lstStyle/>
+          <a:p>
+            <a:pPr>
+              <a:defRPr sz="1400">
+                <a:solidFill>
+                  <a:srgbClr val="5B5B5B"/>
+                </a:solidFill>
+              </a:defRPr>
+            </a:pPr>
+            <a:r>
+              <a:t>Use SalesPredictionApp/ como proyecto principal; el resto son versiones experimentales o de respaldo.</a:t>
+            </a:r>
+          </a:p>
+        </p:txBody>
+      </p:sp>
+      <p:sp>
+        <p:nvSpPr>
+          <p:cNvPr id="4" name="TextBox 3"/>
+          <p:cNvSpPr txBox="1"/>
+          <p:nvPr/>
+        </p:nvSpPr>
+        <p:spPr>
+          <a:xfrm>
+            <a:off x="457200" y="1737360"/>
+            <a:ext cx="8229600" cy="4572000"/>
+          </a:xfrm>
+          <a:prstGeom prst="rect">
+            <a:avLst/>
+          </a:prstGeom>
+          <a:noFill/>
+        </p:spPr>
+        <p:txBody>
+          <a:bodyPr wrap="square">
+            <a:spAutoFit/>
+          </a:bodyPr>
+          <a:lstStyle/>
+          <a:p>
+            <a:pPr>
+              <a:spcAft>
+                <a:spcPts val="1000"/>
+              </a:spcAft>
+              <a:defRPr sz="1600">
+                <a:latin typeface="Consolas"/>
+              </a:defRPr>
+            </a:pPr>
+            <a:r>
+              <a:t>SalesPredictionApp/      → Proyecto principal SDK .NET 10 (objetivo de la tarea)</a:t>
+            </a:r>
+          </a:p>
+          <a:p>
+            <a:pPr>
+              <a:spcAft>
+                <a:spcPts val="1000"/>
+              </a:spcAft>
+              <a:defRPr sz="1600">
+                <a:latin typeface="Consolas"/>
+              </a:defRPr>
+            </a:pPr>
+            <a:r>
+              <a:t>train/                   → Modelo .NET Framework 4.8.1 (no compila sin ajustes)</a:t>
+            </a:r>
+          </a:p>
+          <a:p>
+            <a:pPr>
+              <a:spcAft>
+                <a:spcPts val="1000"/>
+              </a:spcAft>
+              <a:defRPr sz="1600">
+                <a:latin typeface="Consolas"/>
+              </a:defRPr>
+            </a:pPr>
+            <a:r>
+              <a:t>train2/                  → Modelo .NET Framework 4.8.1 reentrenado externamente</a:t>
+            </a:r>
+          </a:p>
+          <a:p>
+            <a:pPr>
+              <a:spcAft>
+                <a:spcPts val="1000"/>
+              </a:spcAft>
+              <a:defRPr sz="1600">
+                <a:latin typeface="Consolas"/>
+              </a:defRPr>
+            </a:pPr>
+            <a:r>
+              <a:t>test/                    → Modelo SDK .NET 10 entrenado con dataset diferente</a:t>
+            </a:r>
+          </a:p>
+          <a:p>
+            <a:pPr>
+              <a:spcAft>
+                <a:spcPts val="1000"/>
+              </a:spcAft>
+              <a:defRPr sz="1600">
+                <a:latin typeface="Consolas"/>
+              </a:defRPr>
+            </a:pPr>
+            <a:r>
+              <a:t>test2/                   → Generador interactivo de predicciones futuras</a:t>
+            </a:r>
+          </a:p>
+          <a:p>
+            <a:pPr>
+              <a:spcAft>
+                <a:spcPts val="1000"/>
+              </a:spcAft>
+              <a:defRPr sz="1600">
+                <a:latin typeface="Consolas"/>
+              </a:defRPr>
+            </a:pPr>
+            <a:r>
+              <a:t>datos/                   → Copia del dataset sintetico</a:t>
+            </a:r>
+          </a:p>
+          <a:p>
+            <a:pPr>
+              <a:spcAft>
+                <a:spcPts val="1000"/>
+              </a:spcAft>
+              <a:defRPr sz="1600">
+                <a:latin typeface="Consolas"/>
+              </a:defRPr>
+            </a:pPr>
+            <a:r>
+              <a:t>powerbi/                 → Dashboard .pbix</a:t>
+            </a:r>
+          </a:p>
+          <a:p>
+            <a:pPr>
+              <a:spcAft>
+                <a:spcPts val="1000"/>
+              </a:spcAft>
+              <a:defRPr sz="1600">
+                <a:latin typeface="Consolas"/>
+              </a:defRPr>
+            </a:pPr>
+            <a:r>
+              <a:t>Scripts Python           → generate_synthetic_sales.py, dashboard_prediccion.py, ...</a:t>
+            </a:r>
+          </a:p>
+        </p:txBody>
+      </p:sp>
+      <p:sp>
+        <p:nvSpPr>
+          <p:cNvPr id="5" name="TextBox 4"/>
+          <p:cNvSpPr txBox="1"/>
+          <p:nvPr/>
+        </p:nvSpPr>
+        <p:spPr>
+          <a:xfrm>
+            <a:off x="457200" y="6035040"/>
+            <a:ext cx="8229600" cy="457200"/>
+          </a:xfrm>
+          <a:prstGeom prst="rect">
+            <a:avLst/>
+          </a:prstGeom>
+          <a:noFill/>
+        </p:spPr>
+        <p:txBody>
+          <a:bodyPr wrap="none">
+            <a:spAutoFit/>
+          </a:bodyPr>
+          <a:lstStyle/>
+          <a:p>
+            <a:pPr>
+              <a:defRPr sz="1200" i="1">
+                <a:solidFill>
+                  <a:srgbClr val="C00000"/>
+                </a:solidFill>
+              </a:defRPr>
+            </a:pPr>
+            <a:r>
+              <a:t>Nota: README.md y AGENTS.md aun mencionan SalesPrediction1/, una carpeta que no existe en el repositorio actual.</a:t>
+            </a:r>
+          </a:p>
+        </p:txBody>
+      </p:sp>
+    </p:spTree>
+  </p:cSld>
+  <p:clrMapOvr>
+    <a:masterClrMapping/>
+  </p:clrMapOvr>
 </p:sld>
 </file>
 
@@ -7636,7 +7821,7 @@
                 <a:ea typeface="Aptos"/>
                 <a:cs typeface="Aptos"/>
               </a:rPr>
-              <a:t>La entrega debe demostrar el proceso, no solo el resultado</a:t>
+              <a:t>La entrega debe demostrar el proceso con el proyecto activo</a:t>
             </a:r>
           </a:p>
         </p:txBody>
@@ -7694,7 +7879,7 @@
                 <a:ea typeface="Aptos"/>
                 <a:cs typeface="Aptos"/>
               </a:rPr>
-              <a:t>Organice evidencias y artefactos para que el trabajo pueda reproducirse.</a:t>
+              <a:t>Organice evidencias desde datos hasta dashboard; use SalesPredictionApp/ como proyecto principal.</a:t>
             </a:r>
           </a:p>
         </p:txBody>
@@ -8379,7 +8564,7 @@
                 <a:ea typeface="Aptos"/>
                 <a:cs typeface="Aptos"/>
               </a:rPr>
-              <a:t>capturas + métricas</a:t>
+              <a:t>capturas de entrenamiento + métricas del modelo</a:t>
             </a:r>
           </a:p>
         </p:txBody>
@@ -8588,7 +8773,7 @@
                 <a:ea typeface="Aptos"/>
                 <a:cs typeface="Aptos"/>
               </a:rPr>
-              <a:t>resultados_prediccion.csv</a:t>
+              <a:t>resultados_prediccion.csv (desde SalesPredictionApp)</a:t>
             </a:r>
           </a:p>
         </p:txBody>
@@ -8797,7 +8982,7 @@
                 <a:ea typeface="Aptos"/>
                 <a:cs typeface="Aptos"/>
               </a:rPr>
-              <a:t>dashboard .xlsx o .pbix</a:t>
+              <a:t>dashboard .xlsx, .pbix o .html</a:t>
             </a:r>
           </a:p>
         </p:txBody>
@@ -9006,7 +9191,7 @@
                 <a:ea typeface="Aptos"/>
                 <a:cs typeface="Aptos"/>
               </a:rPr>
-              <a:t>conclusiones y recomendaciones</a:t>
+              <a:t>conclusiones y recomendaciones de negocio</a:t>
             </a:r>
           </a:p>
         </p:txBody>
@@ -11737,7 +11922,7 @@
                 <a:ea typeface="Aptos"/>
                 <a:cs typeface="Aptos"/>
               </a:rPr>
-              <a:t>En Visual Studio, abra SalesPredictionApp.csproj.</a:t>
+              <a:t>En Visual Studio, abra la carpeta SalesPredictionApp (SDK .NET 10) desde el repositorio.</a:t>
             </a:r>
           </a:p>
         </p:txBody>
@@ -11979,7 +12164,7 @@
                 <a:ea typeface="Aptos"/>
                 <a:cs typeface="Aptos"/>
               </a:rPr>
-              <a:t>Clic derecho en el proyecto → Agregar → Modelo de Machine Learning. Nombre: SalesModel.mbconfig.</a:t>
+              <a:t>Clic derecho en el proyecto → Agregar → Modelo de Machine Learning. Nombre sugerido: SalesModel.mbconfig.</a:t>
             </a:r>
           </a:p>
         </p:txBody>
@@ -12221,7 +12406,7 @@
                 <a:ea typeface="Aptos"/>
                 <a:cs typeface="Aptos"/>
               </a:rPr>
-              <a:t>Seleccione Predicción de valor / Regresión porque total_sales es un valor numérico continuo.</a:t>
+              <a:t>Seleccione Predicción de valor / Regresión porque total_sales es numérico y continuo.</a:t>
             </a:r>
           </a:p>
         </p:txBody>
@@ -14540,76 +14725,10 @@
                 <a:ea typeface="Aptos"/>
                 <a:cs typeface="Aptos"/>
               </a:rPr>
-              <a:t>• Descomentar SalesModel.ModelInput.</a:t>
-            </a:r>
-          </a:p>
-          <a:p xmlns:a="http://schemas.openxmlformats.org/drawingml/2006/main">
-            <a:pPr algn="l">
-              <a:defRPr sz="1500" b="0">
-                <a:solidFill>
-                  <a:srgbClr val="D6EEF2"/>
-                </a:solidFill>
-                <a:latin typeface="Aptos"/>
-                <a:ea typeface="Aptos"/>
-                <a:cs typeface="Aptos"/>
-              </a:defRPr>
-            </a:pPr>
-            <a:r>
-              <a:rPr sz="1500" b="0">
-                <a:solidFill>
-                  <a:srgbClr val="D6EEF2"/>
-                </a:solidFill>
-                <a:latin typeface="Aptos"/>
-                <a:ea typeface="Aptos"/>
-                <a:cs typeface="Aptos"/>
-              </a:rPr>
-              <a:t>• Usar SalesModel.Predict(...).</a:t>
-            </a:r>
-          </a:p>
-          <a:p xmlns:a="http://schemas.openxmlformats.org/drawingml/2006/main">
-            <a:pPr algn="l">
-              <a:defRPr sz="1500" b="0">
-                <a:solidFill>
-                  <a:srgbClr val="D6EEF2"/>
-                </a:solidFill>
-                <a:latin typeface="Aptos"/>
-                <a:ea typeface="Aptos"/>
-                <a:cs typeface="Aptos"/>
-              </a:defRPr>
-            </a:pPr>
-            <a:r>
-              <a:rPr sz="1500" b="0">
-                <a:solidFill>
-                  <a:srgbClr val="D6EEF2"/>
-                </a:solidFill>
-                <a:latin typeface="Aptos"/>
-                <a:ea typeface="Aptos"/>
-                <a:cs typeface="Aptos"/>
-              </a:rPr>
-              <a:t>• Eliminar Random y el bloque ±5 %.</a:t>
-            </a:r>
-          </a:p>
-          <a:p xmlns:a="http://schemas.openxmlformats.org/drawingml/2006/main">
-            <a:pPr algn="l">
-              <a:defRPr sz="1500" b="0">
-                <a:solidFill>
-                  <a:srgbClr val="D6EEF2"/>
-                </a:solidFill>
-                <a:latin typeface="Aptos"/>
-                <a:ea typeface="Aptos"/>
-                <a:cs typeface="Aptos"/>
-              </a:defRPr>
-            </a:pPr>
-            <a:r>
-              <a:rPr sz="1500" b="0">
-                <a:solidFill>
-                  <a:srgbClr val="D6EEF2"/>
-                </a:solidFill>
-                <a:latin typeface="Aptos"/>
-                <a:ea typeface="Aptos"/>
-                <a:cs typeface="Aptos"/>
-              </a:rPr>
-              <a:t>• Mantener CultureInfo.InvariantCulture.</a:t>
+              <a:t>• Descomentar o usar las clases ModelInput/ModelOutput generadas.
+• Invocar el metodo Predict(...) del modelo entrenado.
+• Mantener CultureInfo.InvariantCulture al leer/escribir CSV.
+• Verificar que el nombre del modelo coincida con el archivo .mbconfig.</a:t>
             </a:r>
           </a:p>
         </p:txBody>
@@ -14667,7 +14786,7 @@
                 <a:ea typeface="Aptos"/>
                 <a:cs typeface="Aptos"/>
               </a:rPr>
-              <a:t>Mientras exista la simulación, el CSV no representa un modelo real.</a:t>
+              <a:t>El CSV de salida solo es valido si proviene de predicciones reales del modelo.</a:t>
             </a:r>
           </a:p>
         </p:txBody>

</xml_diff>